<commit_message>
Update 탁구공 빙고 assets, add ZIP slides and bingo reset tip
Co-Authored-By: Claude Opus 4.6 (1M context) <noreply@anthropic.com>
</commit_message>
<xml_diff>
--- a/public/downloads/games/pingpong-bingo/rules.pptx
+++ b/public/downloads/games/pingpong-bingo/rules.pptx
@@ -15,16 +15,12 @@
   <p:notesSz cx="6858000" cy="9144000"/>
   <p:embeddedFontLst>
     <p:embeddedFont>
-      <p:font typeface="Jua" charset="1" panose="00000000000000000000"/>
+      <p:font typeface="무궁화 고딕" charset="1" panose="02020603020101020101"/>
       <p:regular r:id="rId11"/>
     </p:embeddedFont>
     <p:embeddedFont>
-      <p:font typeface="TDTD갬성명조" charset="1" panose="02000503000000000000"/>
+      <p:font typeface="무궁화 고딕 Bold" charset="1" panose="02020603020101020101"/>
       <p:regular r:id="rId12"/>
-    </p:embeddedFont>
-    <p:embeddedFont>
-      <p:font typeface="TDTD가온" charset="1" panose="02000503000000000000"/>
-      <p:regular r:id="rId13"/>
     </p:embeddedFont>
   </p:embeddedFontLst>
   <p:defaultTextStyle>
@@ -3142,8 +3138,8 @@
         </p:nvSpPr>
         <p:spPr>
           <a:xfrm rot="0">
-            <a:off x="1028700" y="3892867"/>
-            <a:ext cx="15555091" cy="2200275"/>
+            <a:off x="1028700" y="4178617"/>
+            <a:ext cx="15555091" cy="1914525"/>
           </a:xfrm>
           <a:prstGeom prst="rect">
             <a:avLst/>
@@ -3165,10 +3161,10 @@
                 <a:solidFill>
                   <a:srgbClr val="FFFAEF"/>
                 </a:solidFill>
-                <a:latin typeface="Jua"/>
-                <a:ea typeface="Jua"/>
-                <a:cs typeface="Jua"/>
-                <a:sym typeface="Jua"/>
+                <a:latin typeface="무궁화 고딕"/>
+                <a:ea typeface="무궁화 고딕"/>
+                <a:cs typeface="무궁화 고딕"/>
+                <a:sym typeface="무궁화 고딕"/>
               </a:rPr>
               <a:t>탁구공 빙고</a:t>
             </a:r>
@@ -3183,8 +3179,8 @@
         </p:nvSpPr>
         <p:spPr>
           <a:xfrm rot="0">
-            <a:off x="15264803" y="9812655"/>
-            <a:ext cx="2637975" cy="474345"/>
+            <a:off x="14382488" y="9822180"/>
+            <a:ext cx="3520291" cy="464820"/>
           </a:xfrm>
           <a:prstGeom prst="rect">
             <a:avLst/>
@@ -3209,10 +3205,10 @@
                 <a:solidFill>
                   <a:srgbClr val="FFFFFF"/>
                 </a:solidFill>
-                <a:latin typeface="TDTD갬성명조"/>
-                <a:ea typeface="TDTD갬성명조"/>
-                <a:cs typeface="TDTD갬성명조"/>
-                <a:sym typeface="TDTD갬성명조"/>
+                <a:latin typeface="무궁화 고딕"/>
+                <a:ea typeface="무궁화 고딕"/>
+                <a:cs typeface="무궁화 고딕"/>
+                <a:sym typeface="무궁화 고딕"/>
               </a:rPr>
               <a:t>ⓒ 2026. Sunday Play</a:t>
             </a:r>
@@ -3361,8 +3357,8 @@
         </p:nvSpPr>
         <p:spPr>
           <a:xfrm rot="0">
-            <a:off x="11392761" y="600705"/>
-            <a:ext cx="5362043" cy="1600200"/>
+            <a:off x="11392761" y="819780"/>
+            <a:ext cx="5362043" cy="1381125"/>
           </a:xfrm>
           <a:prstGeom prst="rect">
             <a:avLst/>
@@ -3384,10 +3380,10 @@
                 <a:solidFill>
                   <a:srgbClr val="FFFAEF"/>
                 </a:solidFill>
-                <a:latin typeface="Jua"/>
-                <a:ea typeface="Jua"/>
-                <a:cs typeface="Jua"/>
-                <a:sym typeface="Jua"/>
+                <a:latin typeface="무궁화 고딕"/>
+                <a:ea typeface="무궁화 고딕"/>
+                <a:cs typeface="무궁화 고딕"/>
+                <a:sym typeface="무궁화 고딕"/>
               </a:rPr>
               <a:t>규칙</a:t>
             </a:r>
@@ -3403,9 +3399,9 @@
         <p:grpSpPr>
           <a:xfrm rot="0">
             <a:off x="309172" y="535073"/>
-            <a:ext cx="11933749" cy="2685740"/>
+            <a:ext cx="11933749" cy="1751019"/>
             <a:chOff x="0" y="0"/>
-            <a:chExt cx="15911666" cy="3580986"/>
+            <a:chExt cx="15911666" cy="2334692"/>
           </a:xfrm>
         </p:grpSpPr>
         <p:sp>
@@ -3416,8 +3412,8 @@
           </p:nvSpPr>
           <p:spPr>
             <a:xfrm rot="0">
-              <a:off x="0" y="1425584"/>
-              <a:ext cx="15911666" cy="2155402"/>
+              <a:off x="0" y="1444634"/>
+              <a:ext cx="15911666" cy="890058"/>
             </a:xfrm>
             <a:prstGeom prst="rect">
               <a:avLst/>
@@ -3431,28 +3427,21 @@
             <a:p>
               <a:pPr algn="l">
                 <a:lnSpc>
-                  <a:spcPts val="6579"/>
+                  <a:spcPts val="5600"/>
                 </a:lnSpc>
               </a:pPr>
               <a:r>
-                <a:rPr lang="en-US" sz="4699">
+                <a:rPr lang="en-US" sz="4000">
                   <a:solidFill>
                     <a:srgbClr val="FFFAEF"/>
                   </a:solidFill>
-                  <a:latin typeface="TDTD가온"/>
-                  <a:ea typeface="TDTD가온"/>
-                  <a:cs typeface="TDTD가온"/>
-                  <a:sym typeface="TDTD가온"/>
+                  <a:latin typeface="무궁화 고딕"/>
+                  <a:ea typeface="무궁화 고딕"/>
+                  <a:cs typeface="무궁화 고딕"/>
+                  <a:sym typeface="무궁화 고딕"/>
                 </a:rPr>
                 <a:t>출발선에서 탁구공을 튕겨 계란판(5×5)에 넣습니다.</a:t>
               </a:r>
-            </a:p>
-            <a:p>
-              <a:pPr algn="l">
-                <a:lnSpc>
-                  <a:spcPts val="6579"/>
-                </a:lnSpc>
-              </a:pPr>
             </a:p>
           </p:txBody>
         </p:sp>
@@ -3464,8 +3453,8 @@
           </p:nvSpPr>
           <p:spPr>
             <a:xfrm rot="0">
-              <a:off x="0" y="-171450"/>
-              <a:ext cx="10684245" cy="1178983"/>
+              <a:off x="0" y="-47625"/>
+              <a:ext cx="10684245" cy="1055158"/>
             </a:xfrm>
             <a:prstGeom prst="rect">
               <a:avLst/>
@@ -3487,10 +3476,10 @@
                   <a:solidFill>
                     <a:srgbClr val="FFFAEF"/>
                   </a:solidFill>
-                  <a:latin typeface="Jua"/>
-                  <a:ea typeface="Jua"/>
-                  <a:cs typeface="Jua"/>
-                  <a:sym typeface="Jua"/>
+                  <a:latin typeface="무궁화 고딕 Bold"/>
+                  <a:ea typeface="무궁화 고딕 Bold"/>
+                  <a:cs typeface="무궁화 고딕 Bold"/>
+                  <a:sym typeface="무궁화 고딕 Bold"/>
                 </a:rPr>
                 <a:t>STEP 1.</a:t>
               </a:r>
@@ -3506,10 +3495,10 @@
         </p:nvGrpSpPr>
         <p:grpSpPr>
           <a:xfrm rot="0">
-            <a:off x="11515372" y="7369547"/>
-            <a:ext cx="6451786" cy="2680876"/>
+            <a:off x="11836214" y="7334434"/>
+            <a:ext cx="6451786" cy="2451005"/>
             <a:chOff x="0" y="0"/>
-            <a:chExt cx="8602382" cy="3574502"/>
+            <a:chExt cx="8602382" cy="3268007"/>
           </a:xfrm>
         </p:grpSpPr>
         <p:sp>
@@ -3520,8 +3509,8 @@
           </p:nvSpPr>
           <p:spPr>
             <a:xfrm rot="0">
-              <a:off x="0" y="1419098"/>
-              <a:ext cx="8602382" cy="2155403"/>
+              <a:off x="0" y="1447673"/>
+              <a:ext cx="8602382" cy="1820333"/>
             </a:xfrm>
             <a:prstGeom prst="rect">
               <a:avLst/>
@@ -3535,30 +3524,30 @@
             <a:p>
               <a:pPr algn="l">
                 <a:lnSpc>
-                  <a:spcPts val="6579"/>
+                  <a:spcPts val="5599"/>
                 </a:lnSpc>
               </a:pPr>
               <a:r>
-                <a:rPr lang="en-US" sz="4699">
+                <a:rPr lang="en-US" sz="3999">
                   <a:solidFill>
                     <a:srgbClr val="FFFAEF"/>
                   </a:solidFill>
-                  <a:latin typeface="TDTD가온"/>
-                  <a:ea typeface="TDTD가온"/>
-                  <a:cs typeface="TDTD가온"/>
-                  <a:sym typeface="TDTD가온"/>
+                  <a:latin typeface="무궁화 고딕"/>
+                  <a:ea typeface="무궁화 고딕"/>
+                  <a:cs typeface="무궁화 고딕"/>
+                  <a:sym typeface="무궁화 고딕"/>
                 </a:rPr>
                 <a:t>가로,</a:t>
               </a:r>
               <a:r>
-                <a:rPr lang="en-US" sz="4699">
+                <a:rPr lang="en-US" sz="3999">
                   <a:solidFill>
                     <a:srgbClr val="FFFAEF"/>
                   </a:solidFill>
-                  <a:latin typeface="TDTD가온"/>
-                  <a:ea typeface="TDTD가온"/>
-                  <a:cs typeface="TDTD가온"/>
-                  <a:sym typeface="TDTD가온"/>
+                  <a:latin typeface="무궁화 고딕"/>
+                  <a:ea typeface="무궁화 고딕"/>
+                  <a:cs typeface="무궁화 고딕"/>
+                  <a:sym typeface="무궁화 고딕"/>
                 </a:rPr>
                 <a:t> 세로, 대각선 빙고를</a:t>
               </a:r>
@@ -3566,18 +3555,18 @@
             <a:p>
               <a:pPr algn="l">
                 <a:lnSpc>
-                  <a:spcPts val="6579"/>
+                  <a:spcPts val="5599"/>
                 </a:lnSpc>
               </a:pPr>
               <a:r>
-                <a:rPr lang="en-US" sz="4699">
+                <a:rPr lang="en-US" sz="3999">
                   <a:solidFill>
                     <a:srgbClr val="FFFAEF"/>
                   </a:solidFill>
-                  <a:latin typeface="TDTD가온"/>
-                  <a:ea typeface="TDTD가온"/>
-                  <a:cs typeface="TDTD가온"/>
-                  <a:sym typeface="TDTD가온"/>
+                  <a:latin typeface="무궁화 고딕"/>
+                  <a:ea typeface="무궁화 고딕"/>
+                  <a:cs typeface="무궁화 고딕"/>
+                  <a:sym typeface="무궁화 고딕"/>
                 </a:rPr>
                 <a:t>먼저 완성한 팀이 우승!</a:t>
               </a:r>
@@ -3592,8 +3581,8 @@
           </p:nvSpPr>
           <p:spPr>
             <a:xfrm rot="0">
-              <a:off x="0" y="-171450"/>
-              <a:ext cx="8602382" cy="1178984"/>
+              <a:off x="0" y="-47625"/>
+              <a:ext cx="8602382" cy="1055159"/>
             </a:xfrm>
             <a:prstGeom prst="rect">
               <a:avLst/>
@@ -3615,10 +3604,10 @@
                   <a:solidFill>
                     <a:srgbClr val="FFFAEF"/>
                   </a:solidFill>
-                  <a:latin typeface="Jua"/>
-                  <a:ea typeface="Jua"/>
-                  <a:cs typeface="Jua"/>
-                  <a:sym typeface="Jua"/>
+                  <a:latin typeface="무궁화 고딕 Bold"/>
+                  <a:ea typeface="무궁화 고딕 Bold"/>
+                  <a:cs typeface="무궁화 고딕 Bold"/>
+                  <a:sym typeface="무궁화 고딕 Bold"/>
                 </a:rPr>
                 <a:t>STEP 3.</a:t>
               </a:r>
@@ -3634,10 +3623,10 @@
         </p:nvGrpSpPr>
         <p:grpSpPr>
           <a:xfrm rot="0">
-            <a:off x="5725278" y="3540404"/>
-            <a:ext cx="7439023" cy="3509551"/>
+            <a:off x="4803898" y="3584760"/>
+            <a:ext cx="7439023" cy="2451005"/>
             <a:chOff x="0" y="0"/>
-            <a:chExt cx="9918697" cy="4679401"/>
+            <a:chExt cx="9918697" cy="3268006"/>
           </a:xfrm>
         </p:grpSpPr>
         <p:sp>
@@ -3648,8 +3637,8 @@
           </p:nvSpPr>
           <p:spPr>
             <a:xfrm rot="0">
-              <a:off x="0" y="1419098"/>
-              <a:ext cx="9918697" cy="3260303"/>
+              <a:off x="0" y="1447673"/>
+              <a:ext cx="9918697" cy="1820333"/>
             </a:xfrm>
             <a:prstGeom prst="rect">
               <a:avLst/>
@@ -3663,18 +3652,18 @@
             <a:p>
               <a:pPr algn="l">
                 <a:lnSpc>
-                  <a:spcPts val="6579"/>
+                  <a:spcPts val="5599"/>
                 </a:lnSpc>
               </a:pPr>
               <a:r>
-                <a:rPr lang="en-US" sz="4699">
+                <a:rPr lang="en-US" sz="3999">
                   <a:solidFill>
                     <a:srgbClr val="FFFAEF"/>
                   </a:solidFill>
-                  <a:latin typeface="TDTD가온"/>
-                  <a:ea typeface="TDTD가온"/>
-                  <a:cs typeface="TDTD가온"/>
-                  <a:sym typeface="TDTD가온"/>
+                  <a:latin typeface="무궁화 고딕"/>
+                  <a:ea typeface="무궁화 고딕"/>
+                  <a:cs typeface="무궁화 고딕"/>
+                  <a:sym typeface="무궁화 고딕"/>
                 </a:rPr>
                 <a:t>공이 들어간 칸을 체크!</a:t>
               </a:r>
@@ -3682,28 +3671,21 @@
             <a:p>
               <a:pPr algn="l">
                 <a:lnSpc>
-                  <a:spcPts val="6579"/>
+                  <a:spcPts val="5599"/>
                 </a:lnSpc>
               </a:pPr>
               <a:r>
-                <a:rPr lang="en-US" sz="4699">
+                <a:rPr lang="en-US" sz="3999">
                   <a:solidFill>
                     <a:srgbClr val="FFFAEF"/>
                   </a:solidFill>
-                  <a:latin typeface="TDTD가온"/>
-                  <a:ea typeface="TDTD가온"/>
-                  <a:cs typeface="TDTD가온"/>
-                  <a:sym typeface="TDTD가온"/>
+                  <a:latin typeface="무궁화 고딕"/>
+                  <a:ea typeface="무궁화 고딕"/>
+                  <a:cs typeface="무궁화 고딕"/>
+                  <a:sym typeface="무궁화 고딕"/>
                 </a:rPr>
                 <a:t>팀원이 한 명씩 번갈아 도전합니다.</a:t>
               </a:r>
-            </a:p>
-            <a:p>
-              <a:pPr algn="l">
-                <a:lnSpc>
-                  <a:spcPts val="6579"/>
-                </a:lnSpc>
-              </a:pPr>
             </a:p>
           </p:txBody>
         </p:sp>
@@ -3715,8 +3697,8 @@
           </p:nvSpPr>
           <p:spPr>
             <a:xfrm rot="0">
-              <a:off x="0" y="-171450"/>
-              <a:ext cx="7235855" cy="1178983"/>
+              <a:off x="0" y="-47625"/>
+              <a:ext cx="7235855" cy="1055158"/>
             </a:xfrm>
             <a:prstGeom prst="rect">
               <a:avLst/>
@@ -3738,10 +3720,10 @@
                   <a:solidFill>
                     <a:srgbClr val="FFFAEF"/>
                   </a:solidFill>
-                  <a:latin typeface="Jua"/>
-                  <a:ea typeface="Jua"/>
-                  <a:cs typeface="Jua"/>
-                  <a:sym typeface="Jua"/>
+                  <a:latin typeface="무궁화 고딕 Bold"/>
+                  <a:ea typeface="무궁화 고딕 Bold"/>
+                  <a:cs typeface="무궁화 고딕 Bold"/>
+                  <a:sym typeface="무궁화 고딕 Bold"/>
                 </a:rPr>
                 <a:t>STEP 2.</a:t>
               </a:r>
@@ -3789,8 +3771,8 @@
         </p:nvSpPr>
         <p:spPr>
           <a:xfrm rot="0">
-            <a:off x="3238925" y="4092795"/>
-            <a:ext cx="11810151" cy="2200275"/>
+            <a:off x="3238925" y="4378545"/>
+            <a:ext cx="11810151" cy="1914525"/>
           </a:xfrm>
           <a:prstGeom prst="rect">
             <a:avLst/>
@@ -3812,10 +3794,10 @@
                 <a:solidFill>
                   <a:srgbClr val="000000"/>
                 </a:solidFill>
-                <a:latin typeface="Jua"/>
-                <a:ea typeface="Jua"/>
-                <a:cs typeface="Jua"/>
-                <a:sym typeface="Jua"/>
+                <a:latin typeface="무궁화 고딕"/>
+                <a:ea typeface="무궁화 고딕"/>
+                <a:cs typeface="무궁화 고딕"/>
+                <a:sym typeface="무궁화 고딕"/>
               </a:rPr>
               <a:t>팀을 나눠주세요!</a:t>
             </a:r>
@@ -3962,8 +3944,8 @@
         </p:nvSpPr>
         <p:spPr>
           <a:xfrm rot="0">
-            <a:off x="1028700" y="3892867"/>
-            <a:ext cx="15555091" cy="2200275"/>
+            <a:off x="1028700" y="4178617"/>
+            <a:ext cx="15555091" cy="1914525"/>
           </a:xfrm>
           <a:prstGeom prst="rect">
             <a:avLst/>
@@ -3985,10 +3967,10 @@
                 <a:solidFill>
                   <a:srgbClr val="FFFAEF"/>
                 </a:solidFill>
-                <a:latin typeface="Jua"/>
-                <a:ea typeface="Jua"/>
-                <a:cs typeface="Jua"/>
-                <a:sym typeface="Jua"/>
+                <a:latin typeface="무궁화 고딕"/>
+                <a:ea typeface="무궁화 고딕"/>
+                <a:cs typeface="무궁화 고딕"/>
+                <a:sym typeface="무궁화 고딕"/>
               </a:rPr>
               <a:t>탁구공 빙고</a:t>
             </a:r>
@@ -4003,8 +3985,8 @@
         </p:nvSpPr>
         <p:spPr>
           <a:xfrm rot="0">
-            <a:off x="15264803" y="9812655"/>
-            <a:ext cx="2637975" cy="474345"/>
+            <a:off x="14382488" y="9822180"/>
+            <a:ext cx="3520291" cy="464820"/>
           </a:xfrm>
           <a:prstGeom prst="rect">
             <a:avLst/>
@@ -4029,10 +4011,10 @@
                 <a:solidFill>
                   <a:srgbClr val="FFFFFF"/>
                 </a:solidFill>
-                <a:latin typeface="TDTD갬성명조"/>
-                <a:ea typeface="TDTD갬성명조"/>
-                <a:cs typeface="TDTD갬성명조"/>
-                <a:sym typeface="TDTD갬성명조"/>
+                <a:latin typeface="무궁화 고딕"/>
+                <a:ea typeface="무궁화 고딕"/>
+                <a:cs typeface="무궁화 고딕"/>
+                <a:sym typeface="무궁화 고딕"/>
               </a:rPr>
               <a:t>ⓒ 2026. Sunday Play</a:t>
             </a:r>
@@ -4104,8 +4086,8 @@
         </p:nvSpPr>
         <p:spPr>
           <a:xfrm rot="0">
-            <a:off x="4421807" y="3895725"/>
-            <a:ext cx="9444385" cy="2200275"/>
+            <a:off x="4421807" y="4181475"/>
+            <a:ext cx="9444385" cy="1914525"/>
           </a:xfrm>
           <a:prstGeom prst="rect">
             <a:avLst/>
@@ -4127,10 +4109,10 @@
                 <a:solidFill>
                   <a:srgbClr val="000000"/>
                 </a:solidFill>
-                <a:latin typeface="Jua"/>
-                <a:ea typeface="Jua"/>
-                <a:cs typeface="Jua"/>
-                <a:sym typeface="Jua"/>
+                <a:latin typeface="무궁화 고딕"/>
+                <a:ea typeface="무궁화 고딕"/>
+                <a:cs typeface="무궁화 고딕"/>
+                <a:sym typeface="무궁화 고딕"/>
               </a:rPr>
               <a:t>감사합니다!</a:t>
             </a:r>

</xml_diff>